<commit_message>
slides: add 6-slide 9-zone deep dive (data9 visualizations)
Inserts a "9-zone study in detail" section using the docs/zones9 figures: zones
map, training curve, marginal recovery, per-cell scatter, OD examples by regime,
and per-regime cell-corr vs ceiling. Deck is now 17 slides.

Co-Authored-By: Claude Opus 4.8 <noreply@anthropic.com>
</commit_message>
<xml_diff>
--- a/slides/OD_36_vs_9_zones.pptx
+++ b/slides/OD_36_vs_9_zones.pptx
@@ -16,6 +16,12 @@
     <p:sldId id="264" r:id="rId15"/>
     <p:sldId id="265" r:id="rId16"/>
     <p:sldId id="266" r:id="rId17"/>
+    <p:sldId id="267" r:id="rId18"/>
+    <p:sldId id="268" r:id="rId19"/>
+    <p:sldId id="269" r:id="rId20"/>
+    <p:sldId id="270" r:id="rId21"/>
+    <p:sldId id="271" r:id="rId22"/>
+    <p:sldId id="272" r:id="rId23"/>
   </p:sldIdLst>
   <p:sldSz cx="12191695" cy="6858000" type="screen4x3"/>
   <p:notesSz cx="6858000" cy="9144000"/>
@@ -3337,21 +3343,45 @@
                 </a:solidFill>
                 <a:latin typeface="Calibri"/>
               </a:rPr>
-              <a:t>Why the numbers differ</a:t>
-            </a:r>
-          </a:p>
-        </p:txBody>
-      </p:sp>
-      <p:sp>
-        <p:nvSpPr>
-          <p:cNvPr id="4" name="TextBox 3"/>
+              <a:t>9-zone study — The 9 TAZ zones</a:t>
+            </a:r>
+          </a:p>
+        </p:txBody>
+      </p:sp>
+      <p:pic>
+        <p:nvPicPr>
+          <p:cNvPr id="4" name="Picture 3" descr="zones_map.png"/>
+          <p:cNvPicPr>
+            <a:picLocks noChangeAspect="1"/>
+          </p:cNvPicPr>
+          <p:nvPr/>
+        </p:nvPicPr>
+        <p:blipFill>
+          <a:blip r:embed="rId2"/>
+          <a:stretch>
+            <a:fillRect/>
+          </a:stretch>
+        </p:blipFill>
+        <p:spPr>
+          <a:xfrm>
+            <a:off x="2812237" y="1143000"/>
+            <a:ext cx="6567220" cy="4925415"/>
+          </a:xfrm>
+          <a:prstGeom prst="rect">
+            <a:avLst/>
+          </a:prstGeom>
+        </p:spPr>
+      </p:pic>
+      <p:sp>
+        <p:nvSpPr>
+          <p:cNvPr id="5" name="TextBox 4"/>
           <p:cNvSpPr txBox="1"/>
           <p:nvPr/>
         </p:nvSpPr>
         <p:spPr>
           <a:xfrm>
-            <a:off x="548640" y="1188720"/>
-            <a:ext cx="11064240" cy="5303520"/>
+            <a:off x="731520" y="6126480"/>
+            <a:ext cx="10698480" cy="640080"/>
           </a:xfrm>
           <a:prstGeom prst="rect">
             <a:avLst/>
@@ -3364,83 +3394,15 @@
           </a:bodyPr>
           <a:lstStyle/>
           <a:p>
-            <a:pPr>
-              <a:spcAft>
-                <a:spcPts val="900"/>
-              </a:spcAft>
-            </a:pPr>
-            <a:r>
-              <a:rPr sz="1600">
+            <a:pPr algn="ctr"/>
+            <a:r>
+              <a:rPr sz="1300" b="0">
                 <a:solidFill>
-                  <a:srgbClr val="222222"/>
+                  <a:srgbClr val="666666"/>
                 </a:solidFill>
                 <a:latin typeface="Calibri"/>
               </a:rPr>
-              <a:t>• More cells ≠ harder here: 36 zones had 1.75× the training data, so its marginal predictor generalises better → higher correlations.</a:t>
-            </a:r>
-          </a:p>
-          <a:p>
-            <a:pPr>
-              <a:spcAft>
-                <a:spcPts val="900"/>
-              </a:spcAft>
-            </a:pPr>
-            <a:r>
-              <a:rPr sz="1600">
-                <a:solidFill>
-                  <a:srgbClr val="222222"/>
-                </a:solidFill>
-                <a:latin typeface="Calibri"/>
-              </a:rPr>
-              <a:t>• Zone balance matters: coarse grids still contain a few tiny edge-of-district zones with little traffic → noisy marginals that drag the pooled 9-zone score down.</a:t>
-            </a:r>
-          </a:p>
-          <a:p>
-            <a:pPr>
-              <a:spcAft>
-                <a:spcPts val="900"/>
-              </a:spcAft>
-            </a:pPr>
-            <a:r>
-              <a:rPr sz="1600">
-                <a:solidFill>
-                  <a:srgbClr val="222222"/>
-                </a:solidFill>
-                <a:latin typeface="Calibri"/>
-              </a:rPr>
-              <a:t>• Scale effect: identical total demand over 72 vs 1260 cells makes 9-zone per-cell trips (and RMSE) ~6× larger — compare normalised RMSE / total-flow error instead.</a:t>
-            </a:r>
-          </a:p>
-          <a:p>
-            <a:pPr>
-              <a:spcAft>
-                <a:spcPts val="900"/>
-              </a:spcAft>
-            </a:pPr>
-            <a:r>
-              <a:rPr sz="1600">
-                <a:solidFill>
-                  <a:srgbClr val="2E7D8C"/>
-                </a:solidFill>
-                <a:latin typeface="Calibri"/>
-              </a:rPr>
-              <a:t>• Coarser OD is more simulation-faithful: 9-zone link-flow GEH = 94% &lt; 5 — excellent for SUMO what-ifs even though its cell-corr is lower.</a:t>
-            </a:r>
-          </a:p>
-          <a:p>
-            <a:pPr>
-              <a:spcAft>
-                <a:spcPts val="900"/>
-              </a:spcAft>
-            </a:pPr>
-            <a:r>
-              <a:rPr sz="1600">
-                <a:solidFill>
-                  <a:srgbClr val="C0392B"/>
-                </a:solidFill>
-                <a:latin typeface="Calibri"/>
-              </a:rPr>
-              <a:t>• Both sit at the gravity ceiling → the limit is information (the observation), not the model. A heavier net or more epochs will not break it.</a:t>
+              <a:t>gridDistricts width 3000. Note the imbalance — central 1_1 and 2_1 dominate while 3_2 / 2_0 / 0_0 are tiny edge cells: the source of the noisier 9-zone marginals.</a:t>
             </a:r>
           </a:p>
         </p:txBody>
@@ -3454,6 +3416,980 @@
 </file>
 
 <file path=ppt/slides/slide11.xml><?xml version="1.0" encoding="utf-8"?>
+<p:sld xmlns:a="http://schemas.openxmlformats.org/drawingml/2006/main" xmlns:p="http://schemas.openxmlformats.org/presentationml/2006/main" xmlns:r="http://schemas.openxmlformats.org/officeDocument/2006/relationships">
+  <p:cSld>
+    <p:spTree>
+      <p:nvGrpSpPr>
+        <p:cNvPr id="1" name=""/>
+        <p:cNvGrpSpPr/>
+        <p:nvPr/>
+      </p:nvGrpSpPr>
+      <p:grpSpPr/>
+      <p:sp>
+        <p:nvSpPr>
+          <p:cNvPr id="2" name="Rectangle 1"/>
+          <p:cNvSpPr/>
+          <p:nvPr/>
+        </p:nvSpPr>
+        <p:spPr>
+          <a:xfrm>
+            <a:off x="0" y="0"/>
+            <a:ext cx="12191695" cy="914400"/>
+          </a:xfrm>
+          <a:prstGeom prst="rect">
+            <a:avLst/>
+          </a:prstGeom>
+          <a:solidFill>
+            <a:srgbClr val="1F3B57"/>
+          </a:solidFill>
+          <a:ln>
+            <a:noFill/>
+          </a:ln>
+        </p:spPr>
+        <p:style>
+          <a:lnRef idx="1">
+            <a:schemeClr val="accent1"/>
+          </a:lnRef>
+          <a:fillRef idx="3">
+            <a:schemeClr val="accent1"/>
+          </a:fillRef>
+          <a:effectRef idx="2">
+            <a:schemeClr val="accent1"/>
+          </a:effectRef>
+          <a:fontRef idx="minor">
+            <a:schemeClr val="lt1"/>
+          </a:fontRef>
+        </p:style>
+        <p:txBody>
+          <a:bodyPr rtlCol="0" anchor="ctr"/>
+          <a:lstStyle/>
+          <a:p>
+            <a:pPr algn="ctr"/>
+          </a:p>
+        </p:txBody>
+      </p:sp>
+      <p:sp>
+        <p:nvSpPr>
+          <p:cNvPr id="3" name="TextBox 2"/>
+          <p:cNvSpPr txBox="1"/>
+          <p:nvPr/>
+        </p:nvSpPr>
+        <p:spPr>
+          <a:xfrm>
+            <a:off x="365760" y="109728"/>
+            <a:ext cx="11430000" cy="731520"/>
+          </a:xfrm>
+          <a:prstGeom prst="rect">
+            <a:avLst/>
+          </a:prstGeom>
+          <a:noFill/>
+        </p:spPr>
+        <p:txBody>
+          <a:bodyPr wrap="square">
+            <a:spAutoFit/>
+          </a:bodyPr>
+          <a:lstStyle/>
+          <a:p>
+            <a:pPr algn="l"/>
+            <a:r>
+              <a:rPr sz="2600" b="1">
+                <a:solidFill>
+                  <a:srgbClr val="FFFFFF"/>
+                </a:solidFill>
+                <a:latin typeface="Calibri"/>
+              </a:rPr>
+              <a:t>9-zone study — Training convergence</a:t>
+            </a:r>
+          </a:p>
+        </p:txBody>
+      </p:sp>
+      <p:pic>
+        <p:nvPicPr>
+          <p:cNvPr id="4" name="Picture 3" descr="training_curve.png"/>
+          <p:cNvPicPr>
+            <a:picLocks noChangeAspect="1"/>
+          </p:cNvPicPr>
+          <p:nvPr/>
+        </p:nvPicPr>
+        <p:blipFill>
+          <a:blip r:embed="rId2"/>
+          <a:stretch>
+            <a:fillRect/>
+          </a:stretch>
+        </p:blipFill>
+        <p:spPr>
+          <a:xfrm>
+            <a:off x="838047" y="1143000"/>
+            <a:ext cx="10515600" cy="3640015"/>
+          </a:xfrm>
+          <a:prstGeom prst="rect">
+            <a:avLst/>
+          </a:prstGeom>
+        </p:spPr>
+      </p:pic>
+      <p:sp>
+        <p:nvSpPr>
+          <p:cNvPr id="5" name="TextBox 4"/>
+          <p:cNvSpPr txBox="1"/>
+          <p:nvPr/>
+        </p:nvSpPr>
+        <p:spPr>
+          <a:xfrm>
+            <a:off x="731520" y="4918775"/>
+            <a:ext cx="10698480" cy="640080"/>
+          </a:xfrm>
+          <a:prstGeom prst="rect">
+            <a:avLst/>
+          </a:prstGeom>
+          <a:noFill/>
+        </p:spPr>
+        <p:txBody>
+          <a:bodyPr wrap="square">
+            <a:spAutoFit/>
+          </a:bodyPr>
+          <a:lstStyle/>
+          <a:p>
+            <a:pPr algn="ctr"/>
+            <a:r>
+              <a:rPr sz="1300" b="0">
+                <a:solidFill>
+                  <a:srgbClr val="666666"/>
+                </a:solidFill>
+                <a:latin typeface="Calibri"/>
+              </a:rPr>
+              <a:t>Per-zone standardized marginal-MSE loss; early-stopped on the validation split.</a:t>
+            </a:r>
+          </a:p>
+        </p:txBody>
+      </p:sp>
+    </p:spTree>
+  </p:cSld>
+  <p:clrMapOvr>
+    <a:masterClrMapping/>
+  </p:clrMapOvr>
+</p:sld>
+</file>
+
+<file path=ppt/slides/slide12.xml><?xml version="1.0" encoding="utf-8"?>
+<p:sld xmlns:a="http://schemas.openxmlformats.org/drawingml/2006/main" xmlns:p="http://schemas.openxmlformats.org/presentationml/2006/main" xmlns:r="http://schemas.openxmlformats.org/officeDocument/2006/relationships">
+  <p:cSld>
+    <p:spTree>
+      <p:nvGrpSpPr>
+        <p:cNvPr id="1" name=""/>
+        <p:cNvGrpSpPr/>
+        <p:nvPr/>
+      </p:nvGrpSpPr>
+      <p:grpSpPr/>
+      <p:sp>
+        <p:nvSpPr>
+          <p:cNvPr id="2" name="Rectangle 1"/>
+          <p:cNvSpPr/>
+          <p:nvPr/>
+        </p:nvSpPr>
+        <p:spPr>
+          <a:xfrm>
+            <a:off x="0" y="0"/>
+            <a:ext cx="12191695" cy="914400"/>
+          </a:xfrm>
+          <a:prstGeom prst="rect">
+            <a:avLst/>
+          </a:prstGeom>
+          <a:solidFill>
+            <a:srgbClr val="1F3B57"/>
+          </a:solidFill>
+          <a:ln>
+            <a:noFill/>
+          </a:ln>
+        </p:spPr>
+        <p:style>
+          <a:lnRef idx="1">
+            <a:schemeClr val="accent1"/>
+          </a:lnRef>
+          <a:fillRef idx="3">
+            <a:schemeClr val="accent1"/>
+          </a:fillRef>
+          <a:effectRef idx="2">
+            <a:schemeClr val="accent1"/>
+          </a:effectRef>
+          <a:fontRef idx="minor">
+            <a:schemeClr val="lt1"/>
+          </a:fontRef>
+        </p:style>
+        <p:txBody>
+          <a:bodyPr rtlCol="0" anchor="ctr"/>
+          <a:lstStyle/>
+          <a:p>
+            <a:pPr algn="ctr"/>
+          </a:p>
+        </p:txBody>
+      </p:sp>
+      <p:sp>
+        <p:nvSpPr>
+          <p:cNvPr id="3" name="TextBox 2"/>
+          <p:cNvSpPr txBox="1"/>
+          <p:nvPr/>
+        </p:nvSpPr>
+        <p:spPr>
+          <a:xfrm>
+            <a:off x="365760" y="109728"/>
+            <a:ext cx="11430000" cy="731520"/>
+          </a:xfrm>
+          <a:prstGeom prst="rect">
+            <a:avLst/>
+          </a:prstGeom>
+          <a:noFill/>
+        </p:spPr>
+        <p:txBody>
+          <a:bodyPr wrap="square">
+            <a:spAutoFit/>
+          </a:bodyPr>
+          <a:lstStyle/>
+          <a:p>
+            <a:pPr algn="l"/>
+            <a:r>
+              <a:rPr sz="2600" b="1">
+                <a:solidFill>
+                  <a:srgbClr val="FFFFFF"/>
+                </a:solidFill>
+                <a:latin typeface="Calibri"/>
+              </a:rPr>
+              <a:t>9-zone study — Marginal recovery (the GNN's actual target)</a:t>
+            </a:r>
+          </a:p>
+        </p:txBody>
+      </p:sp>
+      <p:pic>
+        <p:nvPicPr>
+          <p:cNvPr id="4" name="Picture 3" descr="marginals_scatter.png"/>
+          <p:cNvPicPr>
+            <a:picLocks noChangeAspect="1"/>
+          </p:cNvPicPr>
+          <p:nvPr/>
+        </p:nvPicPr>
+        <p:blipFill>
+          <a:blip r:embed="rId2"/>
+          <a:stretch>
+            <a:fillRect/>
+          </a:stretch>
+        </p:blipFill>
+        <p:spPr>
+          <a:xfrm>
+            <a:off x="838047" y="1143000"/>
+            <a:ext cx="10515600" cy="4819650"/>
+          </a:xfrm>
+          <a:prstGeom prst="rect">
+            <a:avLst/>
+          </a:prstGeom>
+        </p:spPr>
+      </p:pic>
+      <p:sp>
+        <p:nvSpPr>
+          <p:cNvPr id="5" name="TextBox 4"/>
+          <p:cNvSpPr txBox="1"/>
+          <p:nvPr/>
+        </p:nvSpPr>
+        <p:spPr>
+          <a:xfrm>
+            <a:off x="731520" y="6103829"/>
+            <a:ext cx="10698480" cy="640080"/>
+          </a:xfrm>
+          <a:prstGeom prst="rect">
+            <a:avLst/>
+          </a:prstGeom>
+          <a:noFill/>
+        </p:spPr>
+        <p:txBody>
+          <a:bodyPr wrap="square">
+            <a:spAutoFit/>
+          </a:bodyPr>
+          <a:lstStyle/>
+          <a:p>
+            <a:pPr algn="ctr"/>
+            <a:r>
+              <a:rPr sz="1300" b="0">
+                <a:solidFill>
+                  <a:srgbClr val="666666"/>
+                </a:solidFill>
+                <a:latin typeface="Calibri"/>
+              </a:rPr>
+              <a:t>Per-zone production &amp; attraction, predicted vs true — corr 0.82 / 0.80.</a:t>
+            </a:r>
+          </a:p>
+        </p:txBody>
+      </p:sp>
+    </p:spTree>
+  </p:cSld>
+  <p:clrMapOvr>
+    <a:masterClrMapping/>
+  </p:clrMapOvr>
+</p:sld>
+</file>
+
+<file path=ppt/slides/slide13.xml><?xml version="1.0" encoding="utf-8"?>
+<p:sld xmlns:a="http://schemas.openxmlformats.org/drawingml/2006/main" xmlns:p="http://schemas.openxmlformats.org/presentationml/2006/main" xmlns:r="http://schemas.openxmlformats.org/officeDocument/2006/relationships">
+  <p:cSld>
+    <p:spTree>
+      <p:nvGrpSpPr>
+        <p:cNvPr id="1" name=""/>
+        <p:cNvGrpSpPr/>
+        <p:nvPr/>
+      </p:nvGrpSpPr>
+      <p:grpSpPr/>
+      <p:sp>
+        <p:nvSpPr>
+          <p:cNvPr id="2" name="Rectangle 1"/>
+          <p:cNvSpPr/>
+          <p:nvPr/>
+        </p:nvSpPr>
+        <p:spPr>
+          <a:xfrm>
+            <a:off x="0" y="0"/>
+            <a:ext cx="12191695" cy="914400"/>
+          </a:xfrm>
+          <a:prstGeom prst="rect">
+            <a:avLst/>
+          </a:prstGeom>
+          <a:solidFill>
+            <a:srgbClr val="1F3B57"/>
+          </a:solidFill>
+          <a:ln>
+            <a:noFill/>
+          </a:ln>
+        </p:spPr>
+        <p:style>
+          <a:lnRef idx="1">
+            <a:schemeClr val="accent1"/>
+          </a:lnRef>
+          <a:fillRef idx="3">
+            <a:schemeClr val="accent1"/>
+          </a:fillRef>
+          <a:effectRef idx="2">
+            <a:schemeClr val="accent1"/>
+          </a:effectRef>
+          <a:fontRef idx="minor">
+            <a:schemeClr val="lt1"/>
+          </a:fontRef>
+        </p:style>
+        <p:txBody>
+          <a:bodyPr rtlCol="0" anchor="ctr"/>
+          <a:lstStyle/>
+          <a:p>
+            <a:pPr algn="ctr"/>
+          </a:p>
+        </p:txBody>
+      </p:sp>
+      <p:sp>
+        <p:nvSpPr>
+          <p:cNvPr id="3" name="TextBox 2"/>
+          <p:cNvSpPr txBox="1"/>
+          <p:nvPr/>
+        </p:nvSpPr>
+        <p:spPr>
+          <a:xfrm>
+            <a:off x="365760" y="109728"/>
+            <a:ext cx="11430000" cy="731520"/>
+          </a:xfrm>
+          <a:prstGeom prst="rect">
+            <a:avLst/>
+          </a:prstGeom>
+          <a:noFill/>
+        </p:spPr>
+        <p:txBody>
+          <a:bodyPr wrap="square">
+            <a:spAutoFit/>
+          </a:bodyPr>
+          <a:lstStyle/>
+          <a:p>
+            <a:pPr algn="l"/>
+            <a:r>
+              <a:rPr sz="2600" b="1">
+                <a:solidFill>
+                  <a:srgbClr val="FFFFFF"/>
+                </a:solidFill>
+                <a:latin typeface="Calibri"/>
+              </a:rPr>
+              <a:t>9-zone study — Full 9×9 OD per-cell accuracy</a:t>
+            </a:r>
+          </a:p>
+        </p:txBody>
+      </p:sp>
+      <p:pic>
+        <p:nvPicPr>
+          <p:cNvPr id="4" name="Picture 3" descr="cell_scatter.png"/>
+          <p:cNvPicPr>
+            <a:picLocks noChangeAspect="1"/>
+          </p:cNvPicPr>
+          <p:nvPr/>
+        </p:nvPicPr>
+        <p:blipFill>
+          <a:blip r:embed="rId2"/>
+          <a:stretch>
+            <a:fillRect/>
+          </a:stretch>
+        </p:blipFill>
+        <p:spPr>
+          <a:xfrm>
+            <a:off x="3429457" y="1143000"/>
+            <a:ext cx="5332780" cy="4922566"/>
+          </a:xfrm>
+          <a:prstGeom prst="rect">
+            <a:avLst/>
+          </a:prstGeom>
+        </p:spPr>
+      </p:pic>
+      <p:sp>
+        <p:nvSpPr>
+          <p:cNvPr id="5" name="TextBox 4"/>
+          <p:cNvSpPr txBox="1"/>
+          <p:nvPr/>
+        </p:nvSpPr>
+        <p:spPr>
+          <a:xfrm>
+            <a:off x="731520" y="6126480"/>
+            <a:ext cx="10698480" cy="640080"/>
+          </a:xfrm>
+          <a:prstGeom prst="rect">
+            <a:avLst/>
+          </a:prstGeom>
+          <a:noFill/>
+        </p:spPr>
+        <p:txBody>
+          <a:bodyPr wrap="square">
+            <a:spAutoFit/>
+          </a:bodyPr>
+          <a:lstStyle/>
+          <a:p>
+            <a:pPr algn="ctr"/>
+            <a:r>
+              <a:rPr sz="1300" b="0">
+                <a:solidFill>
+                  <a:srgbClr val="666666"/>
+                </a:solidFill>
+                <a:latin typeface="Calibri"/>
+              </a:rPr>
+              <a:t>Pooled predicted vs true off-diagonal cells after gravity reconstruction — cell-corr 0.66.</a:t>
+            </a:r>
+          </a:p>
+        </p:txBody>
+      </p:sp>
+    </p:spTree>
+  </p:cSld>
+  <p:clrMapOvr>
+    <a:masterClrMapping/>
+  </p:clrMapOvr>
+</p:sld>
+</file>
+
+<file path=ppt/slides/slide14.xml><?xml version="1.0" encoding="utf-8"?>
+<p:sld xmlns:a="http://schemas.openxmlformats.org/drawingml/2006/main" xmlns:p="http://schemas.openxmlformats.org/presentationml/2006/main" xmlns:r="http://schemas.openxmlformats.org/officeDocument/2006/relationships">
+  <p:cSld>
+    <p:spTree>
+      <p:nvGrpSpPr>
+        <p:cNvPr id="1" name=""/>
+        <p:cNvGrpSpPr/>
+        <p:nvPr/>
+      </p:nvGrpSpPr>
+      <p:grpSpPr/>
+      <p:sp>
+        <p:nvSpPr>
+          <p:cNvPr id="2" name="Rectangle 1"/>
+          <p:cNvSpPr/>
+          <p:nvPr/>
+        </p:nvSpPr>
+        <p:spPr>
+          <a:xfrm>
+            <a:off x="0" y="0"/>
+            <a:ext cx="12191695" cy="914400"/>
+          </a:xfrm>
+          <a:prstGeom prst="rect">
+            <a:avLst/>
+          </a:prstGeom>
+          <a:solidFill>
+            <a:srgbClr val="1F3B57"/>
+          </a:solidFill>
+          <a:ln>
+            <a:noFill/>
+          </a:ln>
+        </p:spPr>
+        <p:style>
+          <a:lnRef idx="1">
+            <a:schemeClr val="accent1"/>
+          </a:lnRef>
+          <a:fillRef idx="3">
+            <a:schemeClr val="accent1"/>
+          </a:fillRef>
+          <a:effectRef idx="2">
+            <a:schemeClr val="accent1"/>
+          </a:effectRef>
+          <a:fontRef idx="minor">
+            <a:schemeClr val="lt1"/>
+          </a:fontRef>
+        </p:style>
+        <p:txBody>
+          <a:bodyPr rtlCol="0" anchor="ctr"/>
+          <a:lstStyle/>
+          <a:p>
+            <a:pPr algn="ctr"/>
+          </a:p>
+        </p:txBody>
+      </p:sp>
+      <p:sp>
+        <p:nvSpPr>
+          <p:cNvPr id="3" name="TextBox 2"/>
+          <p:cNvSpPr txBox="1"/>
+          <p:nvPr/>
+        </p:nvSpPr>
+        <p:spPr>
+          <a:xfrm>
+            <a:off x="365760" y="109728"/>
+            <a:ext cx="11430000" cy="731520"/>
+          </a:xfrm>
+          <a:prstGeom prst="rect">
+            <a:avLst/>
+          </a:prstGeom>
+          <a:noFill/>
+        </p:spPr>
+        <p:txBody>
+          <a:bodyPr wrap="square">
+            <a:spAutoFit/>
+          </a:bodyPr>
+          <a:lstStyle/>
+          <a:p>
+            <a:pPr algn="l"/>
+            <a:r>
+              <a:rPr sz="2600" b="1">
+                <a:solidFill>
+                  <a:srgbClr val="FFFFFF"/>
+                </a:solidFill>
+                <a:latin typeface="Calibri"/>
+              </a:rPr>
+              <a:t>9-zone study — Example OD matrices by regime</a:t>
+            </a:r>
+          </a:p>
+        </p:txBody>
+      </p:sp>
+      <p:pic>
+        <p:nvPicPr>
+          <p:cNvPr id="4" name="Picture 3" descr="od_examples.png"/>
+          <p:cNvPicPr>
+            <a:picLocks noChangeAspect="1"/>
+          </p:cNvPicPr>
+          <p:nvPr/>
+        </p:nvPicPr>
+        <p:blipFill>
+          <a:blip r:embed="rId2"/>
+          <a:stretch>
+            <a:fillRect/>
+          </a:stretch>
+        </p:blipFill>
+        <p:spPr>
+          <a:xfrm>
+            <a:off x="1429664" y="1143000"/>
+            <a:ext cx="9332366" cy="4927759"/>
+          </a:xfrm>
+          <a:prstGeom prst="rect">
+            <a:avLst/>
+          </a:prstGeom>
+        </p:spPr>
+      </p:pic>
+      <p:sp>
+        <p:nvSpPr>
+          <p:cNvPr id="5" name="TextBox 4"/>
+          <p:cNvSpPr txBox="1"/>
+          <p:nvPr/>
+        </p:nvSpPr>
+        <p:spPr>
+          <a:xfrm>
+            <a:off x="731520" y="6126480"/>
+            <a:ext cx="10698480" cy="640080"/>
+          </a:xfrm>
+          <a:prstGeom prst="rect">
+            <a:avLst/>
+          </a:prstGeom>
+          <a:noFill/>
+        </p:spPr>
+        <p:txBody>
+          <a:bodyPr wrap="square">
+            <a:spAutoFit/>
+          </a:bodyPr>
+          <a:lstStyle/>
+          <a:p>
+            <a:pPr algn="ctr"/>
+            <a:r>
+              <a:rPr sz="1300" b="0">
+                <a:solidFill>
+                  <a:srgbClr val="666666"/>
+                </a:solidFill>
+                <a:latin typeface="Calibri"/>
+              </a:rPr>
+              <a:t>Predicted vs true OD across night / noon / morning-peak / evening-peak — gravity-smoothed, right structure.</a:t>
+            </a:r>
+          </a:p>
+        </p:txBody>
+      </p:sp>
+    </p:spTree>
+  </p:cSld>
+  <p:clrMapOvr>
+    <a:masterClrMapping/>
+  </p:clrMapOvr>
+</p:sld>
+</file>
+
+<file path=ppt/slides/slide15.xml><?xml version="1.0" encoding="utf-8"?>
+<p:sld xmlns:a="http://schemas.openxmlformats.org/drawingml/2006/main" xmlns:p="http://schemas.openxmlformats.org/presentationml/2006/main" xmlns:r="http://schemas.openxmlformats.org/officeDocument/2006/relationships">
+  <p:cSld>
+    <p:spTree>
+      <p:nvGrpSpPr>
+        <p:cNvPr id="1" name=""/>
+        <p:cNvGrpSpPr/>
+        <p:nvPr/>
+      </p:nvGrpSpPr>
+      <p:grpSpPr/>
+      <p:sp>
+        <p:nvSpPr>
+          <p:cNvPr id="2" name="Rectangle 1"/>
+          <p:cNvSpPr/>
+          <p:nvPr/>
+        </p:nvSpPr>
+        <p:spPr>
+          <a:xfrm>
+            <a:off x="0" y="0"/>
+            <a:ext cx="12191695" cy="914400"/>
+          </a:xfrm>
+          <a:prstGeom prst="rect">
+            <a:avLst/>
+          </a:prstGeom>
+          <a:solidFill>
+            <a:srgbClr val="1F3B57"/>
+          </a:solidFill>
+          <a:ln>
+            <a:noFill/>
+          </a:ln>
+        </p:spPr>
+        <p:style>
+          <a:lnRef idx="1">
+            <a:schemeClr val="accent1"/>
+          </a:lnRef>
+          <a:fillRef idx="3">
+            <a:schemeClr val="accent1"/>
+          </a:fillRef>
+          <a:effectRef idx="2">
+            <a:schemeClr val="accent1"/>
+          </a:effectRef>
+          <a:fontRef idx="minor">
+            <a:schemeClr val="lt1"/>
+          </a:fontRef>
+        </p:style>
+        <p:txBody>
+          <a:bodyPr rtlCol="0" anchor="ctr"/>
+          <a:lstStyle/>
+          <a:p>
+            <a:pPr algn="ctr"/>
+          </a:p>
+        </p:txBody>
+      </p:sp>
+      <p:sp>
+        <p:nvSpPr>
+          <p:cNvPr id="3" name="TextBox 2"/>
+          <p:cNvSpPr txBox="1"/>
+          <p:nvPr/>
+        </p:nvSpPr>
+        <p:spPr>
+          <a:xfrm>
+            <a:off x="365760" y="109728"/>
+            <a:ext cx="11430000" cy="731520"/>
+          </a:xfrm>
+          <a:prstGeom prst="rect">
+            <a:avLst/>
+          </a:prstGeom>
+          <a:noFill/>
+        </p:spPr>
+        <p:txBody>
+          <a:bodyPr wrap="square">
+            <a:spAutoFit/>
+          </a:bodyPr>
+          <a:lstStyle/>
+          <a:p>
+            <a:pPr algn="l"/>
+            <a:r>
+              <a:rPr sz="2600" b="1">
+                <a:solidFill>
+                  <a:srgbClr val="FFFFFF"/>
+                </a:solidFill>
+                <a:latin typeface="Calibri"/>
+              </a:rPr>
+              <a:t>9-zone study — OD cell-corr by regime vs the ceiling</a:t>
+            </a:r>
+          </a:p>
+        </p:txBody>
+      </p:sp>
+      <p:pic>
+        <p:nvPicPr>
+          <p:cNvPr id="4" name="Picture 3" descr="metrics_summary.png"/>
+          <p:cNvPicPr>
+            <a:picLocks noChangeAspect="1"/>
+          </p:cNvPicPr>
+          <p:nvPr/>
+        </p:nvPicPr>
+        <p:blipFill>
+          <a:blip r:embed="rId2"/>
+          <a:stretch>
+            <a:fillRect/>
+          </a:stretch>
+        </p:blipFill>
+        <p:spPr>
+          <a:xfrm>
+            <a:off x="1898751" y="1143000"/>
+            <a:ext cx="8394192" cy="4937760"/>
+          </a:xfrm>
+          <a:prstGeom prst="rect">
+            <a:avLst/>
+          </a:prstGeom>
+        </p:spPr>
+      </p:pic>
+      <p:sp>
+        <p:nvSpPr>
+          <p:cNvPr id="5" name="TextBox 4"/>
+          <p:cNvSpPr txBox="1"/>
+          <p:nvPr/>
+        </p:nvSpPr>
+        <p:spPr>
+          <a:xfrm>
+            <a:off x="731520" y="6126480"/>
+            <a:ext cx="10698480" cy="640080"/>
+          </a:xfrm>
+          <a:prstGeom prst="rect">
+            <a:avLst/>
+          </a:prstGeom>
+          <a:noFill/>
+        </p:spPr>
+        <p:txBody>
+          <a:bodyPr wrap="square">
+            <a:spAutoFit/>
+          </a:bodyPr>
+          <a:lstStyle/>
+          <a:p>
+            <a:pPr algn="ctr"/>
+            <a:r>
+              <a:rPr sz="1300" b="0">
+                <a:solidFill>
+                  <a:srgbClr val="666666"/>
+                </a:solidFill>
+                <a:latin typeface="Calibri"/>
+              </a:rPr>
+              <a:t>Peaks are strong (~0.74–0.79); night is the weak spot (0.17, sparse demand). Ceiling = 0.88.</a:t>
+            </a:r>
+          </a:p>
+        </p:txBody>
+      </p:sp>
+    </p:spTree>
+  </p:cSld>
+  <p:clrMapOvr>
+    <a:masterClrMapping/>
+  </p:clrMapOvr>
+</p:sld>
+</file>
+
+<file path=ppt/slides/slide16.xml><?xml version="1.0" encoding="utf-8"?>
+<p:sld xmlns:a="http://schemas.openxmlformats.org/drawingml/2006/main" xmlns:p="http://schemas.openxmlformats.org/presentationml/2006/main" xmlns:r="http://schemas.openxmlformats.org/officeDocument/2006/relationships">
+  <p:cSld>
+    <p:spTree>
+      <p:nvGrpSpPr>
+        <p:cNvPr id="1" name=""/>
+        <p:cNvGrpSpPr/>
+        <p:nvPr/>
+      </p:nvGrpSpPr>
+      <p:grpSpPr/>
+      <p:sp>
+        <p:nvSpPr>
+          <p:cNvPr id="2" name="Rectangle 1"/>
+          <p:cNvSpPr/>
+          <p:nvPr/>
+        </p:nvSpPr>
+        <p:spPr>
+          <a:xfrm>
+            <a:off x="0" y="0"/>
+            <a:ext cx="12191695" cy="914400"/>
+          </a:xfrm>
+          <a:prstGeom prst="rect">
+            <a:avLst/>
+          </a:prstGeom>
+          <a:solidFill>
+            <a:srgbClr val="1F3B57"/>
+          </a:solidFill>
+          <a:ln>
+            <a:noFill/>
+          </a:ln>
+        </p:spPr>
+        <p:style>
+          <a:lnRef idx="1">
+            <a:schemeClr val="accent1"/>
+          </a:lnRef>
+          <a:fillRef idx="3">
+            <a:schemeClr val="accent1"/>
+          </a:fillRef>
+          <a:effectRef idx="2">
+            <a:schemeClr val="accent1"/>
+          </a:effectRef>
+          <a:fontRef idx="minor">
+            <a:schemeClr val="lt1"/>
+          </a:fontRef>
+        </p:style>
+        <p:txBody>
+          <a:bodyPr rtlCol="0" anchor="ctr"/>
+          <a:lstStyle/>
+          <a:p>
+            <a:pPr algn="ctr"/>
+          </a:p>
+        </p:txBody>
+      </p:sp>
+      <p:sp>
+        <p:nvSpPr>
+          <p:cNvPr id="3" name="TextBox 2"/>
+          <p:cNvSpPr txBox="1"/>
+          <p:nvPr/>
+        </p:nvSpPr>
+        <p:spPr>
+          <a:xfrm>
+            <a:off x="365760" y="109728"/>
+            <a:ext cx="11430000" cy="731520"/>
+          </a:xfrm>
+          <a:prstGeom prst="rect">
+            <a:avLst/>
+          </a:prstGeom>
+          <a:noFill/>
+        </p:spPr>
+        <p:txBody>
+          <a:bodyPr wrap="square">
+            <a:spAutoFit/>
+          </a:bodyPr>
+          <a:lstStyle/>
+          <a:p>
+            <a:pPr algn="l"/>
+            <a:r>
+              <a:rPr sz="2600" b="1">
+                <a:solidFill>
+                  <a:srgbClr val="FFFFFF"/>
+                </a:solidFill>
+                <a:latin typeface="Calibri"/>
+              </a:rPr>
+              <a:t>Why the numbers differ</a:t>
+            </a:r>
+          </a:p>
+        </p:txBody>
+      </p:sp>
+      <p:sp>
+        <p:nvSpPr>
+          <p:cNvPr id="4" name="TextBox 3"/>
+          <p:cNvSpPr txBox="1"/>
+          <p:nvPr/>
+        </p:nvSpPr>
+        <p:spPr>
+          <a:xfrm>
+            <a:off x="548640" y="1188720"/>
+            <a:ext cx="11064240" cy="5303520"/>
+          </a:xfrm>
+          <a:prstGeom prst="rect">
+            <a:avLst/>
+          </a:prstGeom>
+          <a:noFill/>
+        </p:spPr>
+        <p:txBody>
+          <a:bodyPr wrap="square">
+            <a:spAutoFit/>
+          </a:bodyPr>
+          <a:lstStyle/>
+          <a:p>
+            <a:pPr>
+              <a:spcAft>
+                <a:spcPts val="900"/>
+              </a:spcAft>
+            </a:pPr>
+            <a:r>
+              <a:rPr sz="1600">
+                <a:solidFill>
+                  <a:srgbClr val="222222"/>
+                </a:solidFill>
+                <a:latin typeface="Calibri"/>
+              </a:rPr>
+              <a:t>• More cells ≠ harder here: 36 zones had 1.75× the training data, so its marginal predictor generalises better → higher correlations.</a:t>
+            </a:r>
+          </a:p>
+          <a:p>
+            <a:pPr>
+              <a:spcAft>
+                <a:spcPts val="900"/>
+              </a:spcAft>
+            </a:pPr>
+            <a:r>
+              <a:rPr sz="1600">
+                <a:solidFill>
+                  <a:srgbClr val="222222"/>
+                </a:solidFill>
+                <a:latin typeface="Calibri"/>
+              </a:rPr>
+              <a:t>• Zone balance matters: coarse grids still contain a few tiny edge-of-district zones with little traffic → noisy marginals that drag the pooled 9-zone score down.</a:t>
+            </a:r>
+          </a:p>
+          <a:p>
+            <a:pPr>
+              <a:spcAft>
+                <a:spcPts val="900"/>
+              </a:spcAft>
+            </a:pPr>
+            <a:r>
+              <a:rPr sz="1600">
+                <a:solidFill>
+                  <a:srgbClr val="222222"/>
+                </a:solidFill>
+                <a:latin typeface="Calibri"/>
+              </a:rPr>
+              <a:t>• Scale effect: identical total demand over 72 vs 1260 cells makes 9-zone per-cell trips (and RMSE) ~6× larger — compare normalised RMSE / total-flow error instead.</a:t>
+            </a:r>
+          </a:p>
+          <a:p>
+            <a:pPr>
+              <a:spcAft>
+                <a:spcPts val="900"/>
+              </a:spcAft>
+            </a:pPr>
+            <a:r>
+              <a:rPr sz="1600">
+                <a:solidFill>
+                  <a:srgbClr val="2E7D8C"/>
+                </a:solidFill>
+                <a:latin typeface="Calibri"/>
+              </a:rPr>
+              <a:t>• Coarser OD is more simulation-faithful: 9-zone link-flow GEH = 94% &lt; 5 — excellent for SUMO what-ifs even though its cell-corr is lower.</a:t>
+            </a:r>
+          </a:p>
+          <a:p>
+            <a:pPr>
+              <a:spcAft>
+                <a:spcPts val="900"/>
+              </a:spcAft>
+            </a:pPr>
+            <a:r>
+              <a:rPr sz="1600">
+                <a:solidFill>
+                  <a:srgbClr val="C0392B"/>
+                </a:solidFill>
+                <a:latin typeface="Calibri"/>
+              </a:rPr>
+              <a:t>• Both sit at the gravity ceiling → the limit is information (the observation), not the model. A heavier net or more epochs will not break it.</a:t>
+            </a:r>
+          </a:p>
+        </p:txBody>
+      </p:sp>
+    </p:spTree>
+  </p:cSld>
+  <p:clrMapOvr>
+    <a:masterClrMapping/>
+  </p:clrMapOvr>
+</p:sld>
+</file>
+
+<file path=ppt/slides/slide17.xml><?xml version="1.0" encoding="utf-8"?>
 <p:sld xmlns:a="http://schemas.openxmlformats.org/drawingml/2006/main" xmlns:p="http://schemas.openxmlformats.org/presentationml/2006/main" xmlns:r="http://schemas.openxmlformats.org/officeDocument/2006/relationships">
   <p:cSld>
     <p:spTree>

</xml_diff>